<commit_message>
Quartz sync: Aug 26, 2025, 6:48 PM
</commit_message>
<xml_diff>
--- a/content/Articles/session34tokens.pptx
+++ b/content/Articles/session34tokens.pptx
@@ -116,7 +116,7 @@
 <file path=ppt/revisionInfo.xml><?xml version="1.0" encoding="utf-8"?>
 <p1510:revInfo xmlns:a="http://schemas.openxmlformats.org/drawingml/2006/main" xmlns:r="http://schemas.openxmlformats.org/officeDocument/2006/relationships" xmlns:p1510="http://schemas.microsoft.com/office/powerpoint/2015/10/main">
   <p1510:revLst>
-    <p1510:client id="{5EC4AB4B-B52D-4C64-A18D-BF73A811A050}" v="423" dt="2025-08-26T03:05:21.942"/>
+    <p1510:client id="{5EC4AB4B-B52D-4C64-A18D-BF73A811A050}" v="441" dt="2025-08-26T19:07:21.793"/>
   </p1510:revLst>
 </p1510:revInfo>
 </file>
@@ -314,7 +314,7 @@
   <pc:docChgLst>
     <pc:chgData name="Jack Bond" userId="d0613b4d9d68792d" providerId="LiveId" clId="{5EC4AB4B-B52D-4C64-A18D-BF73A811A050}"/>
     <pc:docChg chg="undo custSel addSld delSld modSld">
-      <pc:chgData name="Jack Bond" userId="d0613b4d9d68792d" providerId="LiveId" clId="{5EC4AB4B-B52D-4C64-A18D-BF73A811A050}" dt="2025-08-26T03:05:21.942" v="557"/>
+      <pc:chgData name="Jack Bond" userId="d0613b4d9d68792d" providerId="LiveId" clId="{5EC4AB4B-B52D-4C64-A18D-BF73A811A050}" dt="2025-08-26T19:07:21.793" v="576" actId="1076"/>
       <pc:docMkLst>
         <pc:docMk/>
       </pc:docMkLst>
@@ -333,7 +333,7 @@
         </pc:sldMkLst>
       </pc:sldChg>
       <pc:sldChg chg="addSp delSp modSp new mod">
-        <pc:chgData name="Jack Bond" userId="d0613b4d9d68792d" providerId="LiveId" clId="{5EC4AB4B-B52D-4C64-A18D-BF73A811A050}" dt="2025-08-26T02:48:30.634" v="550" actId="1076"/>
+        <pc:chgData name="Jack Bond" userId="d0613b4d9d68792d" providerId="LiveId" clId="{5EC4AB4B-B52D-4C64-A18D-BF73A811A050}" dt="2025-08-26T19:07:21.793" v="576" actId="1076"/>
         <pc:sldMkLst>
           <pc:docMk/>
           <pc:sldMk cId="3096770309" sldId="272"/>
@@ -370,12 +370,20 @@
             <ac:spMk id="12" creationId="{DB7766B2-0B29-AFFB-6C41-F97CCD093283}"/>
           </ac:spMkLst>
         </pc:spChg>
-        <pc:grpChg chg="add mod">
-          <ac:chgData name="Jack Bond" userId="d0613b4d9d68792d" providerId="LiveId" clId="{5EC4AB4B-B52D-4C64-A18D-BF73A811A050}" dt="2025-08-26T00:45:15.883" v="478" actId="1076"/>
+        <pc:grpChg chg="add del mod">
+          <ac:chgData name="Jack Bond" userId="d0613b4d9d68792d" providerId="LiveId" clId="{5EC4AB4B-B52D-4C64-A18D-BF73A811A050}" dt="2025-08-26T19:06:35.704" v="561" actId="478"/>
           <ac:grpSpMkLst>
             <pc:docMk/>
             <pc:sldMk cId="3096770309" sldId="272"/>
             <ac:grpSpMk id="10" creationId="{D394A966-B6CA-D0CB-901D-B912A8B12CF0}"/>
+          </ac:grpSpMkLst>
+        </pc:grpChg>
+        <pc:grpChg chg="add mod">
+          <ac:chgData name="Jack Bond" userId="d0613b4d9d68792d" providerId="LiveId" clId="{5EC4AB4B-B52D-4C64-A18D-BF73A811A050}" dt="2025-08-26T19:07:21.793" v="576" actId="1076"/>
+          <ac:grpSpMkLst>
+            <pc:docMk/>
+            <pc:sldMk cId="3096770309" sldId="272"/>
+            <ac:grpSpMk id="22" creationId="{46F9933D-CB73-2541-E1E8-126BD76BF377}"/>
           </ac:grpSpMkLst>
         </pc:grpChg>
         <pc:picChg chg="add del mod">
@@ -443,7 +451,7 @@
           </ac:picMkLst>
         </pc:picChg>
         <pc:picChg chg="add mod">
-          <ac:chgData name="Jack Bond" userId="d0613b4d9d68792d" providerId="LiveId" clId="{5EC4AB4B-B52D-4C64-A18D-BF73A811A050}" dt="2025-08-26T02:48:30.634" v="550" actId="1076"/>
+          <ac:chgData name="Jack Bond" userId="d0613b4d9d68792d" providerId="LiveId" clId="{5EC4AB4B-B52D-4C64-A18D-BF73A811A050}" dt="2025-08-26T19:07:19.401" v="575" actId="1076"/>
           <ac:picMkLst>
             <pc:docMk/>
             <pc:sldMk cId="3096770309" sldId="272"/>
@@ -456,6 +464,14 @@
             <pc:docMk/>
             <pc:sldMk cId="3096770309" sldId="272"/>
             <ac:picMk id="20" creationId="{E2ABDBCD-044D-8FEC-7BAD-58C6994EA3DB}"/>
+          </ac:picMkLst>
+        </pc:picChg>
+        <pc:picChg chg="add mod">
+          <ac:chgData name="Jack Bond" userId="d0613b4d9d68792d" providerId="LiveId" clId="{5EC4AB4B-B52D-4C64-A18D-BF73A811A050}" dt="2025-08-26T19:07:21.793" v="576" actId="1076"/>
+          <ac:picMkLst>
+            <pc:docMk/>
+            <pc:sldMk cId="3096770309" sldId="272"/>
+            <ac:picMk id="21" creationId="{BCDF1A1A-629F-F682-1530-12D5FD23FF85}"/>
           </ac:picMkLst>
         </pc:picChg>
         <pc:picChg chg="add del mod">
@@ -482,15 +498,23 @@
             <ac:picMk id="1030" creationId="{FAF4EB28-1C95-7881-9F34-F949B389F70C}"/>
           </ac:picMkLst>
         </pc:picChg>
+        <pc:picChg chg="add mod">
+          <ac:chgData name="Jack Bond" userId="d0613b4d9d68792d" providerId="LiveId" clId="{5EC4AB4B-B52D-4C64-A18D-BF73A811A050}" dt="2025-08-26T19:07:21.793" v="576" actId="1076"/>
+          <ac:picMkLst>
+            <pc:docMk/>
+            <pc:sldMk cId="3096770309" sldId="272"/>
+            <ac:picMk id="1036" creationId="{5FEE716B-E3B0-F16F-0D0C-CAB7F7B13D3A}"/>
+          </ac:picMkLst>
+        </pc:picChg>
       </pc:sldChg>
       <pc:sldChg chg="addSp modSp new mod">
-        <pc:chgData name="Jack Bond" userId="d0613b4d9d68792d" providerId="LiveId" clId="{5EC4AB4B-B52D-4C64-A18D-BF73A811A050}" dt="2025-08-26T03:05:21.942" v="557"/>
+        <pc:chgData name="Jack Bond" userId="d0613b4d9d68792d" providerId="LiveId" clId="{5EC4AB4B-B52D-4C64-A18D-BF73A811A050}" dt="2025-08-26T03:05:48.581" v="558"/>
         <pc:sldMkLst>
           <pc:docMk/>
           <pc:sldMk cId="3795993947" sldId="273"/>
         </pc:sldMkLst>
         <pc:picChg chg="add mod">
-          <ac:chgData name="Jack Bond" userId="d0613b4d9d68792d" providerId="LiveId" clId="{5EC4AB4B-B52D-4C64-A18D-BF73A811A050}" dt="2025-08-26T03:05:21.942" v="557"/>
+          <ac:chgData name="Jack Bond" userId="d0613b4d9d68792d" providerId="LiveId" clId="{5EC4AB4B-B52D-4C64-A18D-BF73A811A050}" dt="2025-08-26T03:05:48.581" v="558"/>
           <ac:picMkLst>
             <pc:docMk/>
             <pc:sldMk cId="3795993947" sldId="273"/>
@@ -3362,109 +3386,48 @@
           <a:chExt cx="0" cy="0"/>
         </a:xfrm>
       </p:grpSpPr>
-      <p:grpSp>
-        <p:nvGrpSpPr>
-          <p:cNvPr id="10" name="Group 9">
-            <a:extLst>
-              <a:ext uri="{FF2B5EF4-FFF2-40B4-BE49-F238E27FC236}">
-                <a16:creationId xmlns:a16="http://schemas.microsoft.com/office/drawing/2014/main" id="{D394A966-B6CA-D0CB-901D-B912A8B12CF0}"/>
-              </a:ext>
-            </a:extLst>
-          </p:cNvPr>
-          <p:cNvGrpSpPr/>
-          <p:nvPr/>
-        </p:nvGrpSpPr>
-        <p:grpSpPr>
-          <a:xfrm>
-            <a:off x="512064" y="1503219"/>
-            <a:ext cx="2457062" cy="7051962"/>
-            <a:chOff x="1115568" y="980984"/>
-            <a:chExt cx="2457062" cy="7051962"/>
-          </a:xfrm>
-        </p:grpSpPr>
-        <p:pic>
-          <p:nvPicPr>
-            <p:cNvPr id="7" name="Picture 6">
-              <a:extLst>
-                <a:ext uri="{FF2B5EF4-FFF2-40B4-BE49-F238E27FC236}">
-                  <a16:creationId xmlns:a16="http://schemas.microsoft.com/office/drawing/2014/main" id="{B26C975C-E0E2-8B40-424E-F2C4D9004AE6}"/>
-                </a:ext>
-              </a:extLst>
-            </p:cNvPr>
-            <p:cNvPicPr>
-              <a:picLocks noChangeAspect="1"/>
-            </p:cNvPicPr>
-            <p:nvPr/>
-          </p:nvPicPr>
-          <p:blipFill>
-            <a:blip r:embed="rId2">
-              <a:duotone>
-                <a:prstClr val="black"/>
-                <a:srgbClr val="C73001">
-                  <a:tint val="45000"/>
-                  <a:satMod val="400000"/>
-                </a:srgbClr>
-              </a:duotone>
-            </a:blip>
-            <a:stretch>
-              <a:fillRect/>
-            </a:stretch>
-          </p:blipFill>
-          <p:spPr>
-            <a:xfrm>
-              <a:off x="1115569" y="980984"/>
-              <a:ext cx="2457061" cy="3657600"/>
-            </a:xfrm>
-            <a:prstGeom prst="rect">
-              <a:avLst/>
-            </a:prstGeom>
-          </p:spPr>
-        </p:pic>
-        <p:pic>
-          <p:nvPicPr>
-            <p:cNvPr id="9" name="Picture 8">
-              <a:extLst>
-                <a:ext uri="{FF2B5EF4-FFF2-40B4-BE49-F238E27FC236}">
-                  <a16:creationId xmlns:a16="http://schemas.microsoft.com/office/drawing/2014/main" id="{0C1EBAAA-99BB-51B1-22C4-B56FCE1E6699}"/>
-                </a:ext>
-              </a:extLst>
-            </p:cNvPr>
-            <p:cNvPicPr>
-              <a:picLocks noChangeAspect="1"/>
-            </p:cNvPicPr>
-            <p:nvPr/>
-          </p:nvPicPr>
-          <p:blipFill>
-            <a:blip r:embed="rId2">
-              <a:duotone>
-                <a:prstClr val="black"/>
-                <a:srgbClr val="C73001">
-                  <a:tint val="45000"/>
-                  <a:satMod val="400000"/>
-                </a:srgbClr>
-              </a:duotone>
-            </a:blip>
-            <a:stretch>
-              <a:fillRect/>
-            </a:stretch>
-          </p:blipFill>
-          <p:spPr>
-            <a:xfrm flipV="1">
-              <a:off x="1115568" y="4375347"/>
-              <a:ext cx="2457061" cy="3657599"/>
-            </a:xfrm>
-            <a:prstGeom prst="rect">
-              <a:avLst/>
-            </a:prstGeom>
-          </p:spPr>
-        </p:pic>
-      </p:grpSp>
       <p:pic>
         <p:nvPicPr>
           <p:cNvPr id="18" name="Picture 17" descr="A white card with a bird&#10;&#10;AI-generated content may be incorrect.">
             <a:extLst>
               <a:ext uri="{FF2B5EF4-FFF2-40B4-BE49-F238E27FC236}">
                 <a16:creationId xmlns:a16="http://schemas.microsoft.com/office/drawing/2014/main" id="{A3FE72A6-476D-FF26-FCB7-A360C1655EAB}"/>
+              </a:ext>
+            </a:extLst>
+          </p:cNvPr>
+          <p:cNvPicPr>
+            <a:picLocks noChangeAspect="1"/>
+          </p:cNvPicPr>
+          <p:nvPr/>
+        </p:nvPicPr>
+        <p:blipFill>
+          <a:blip r:embed="rId2">
+            <a:extLst>
+              <a:ext uri="{28A0092B-C50C-407E-A947-70E740481C1C}">
+                <a14:useLocalDpi xmlns:a14="http://schemas.microsoft.com/office/drawing/2010/main" val="0"/>
+              </a:ext>
+            </a:extLst>
+          </a:blip>
+          <a:stretch>
+            <a:fillRect/>
+          </a:stretch>
+        </p:blipFill>
+        <p:spPr>
+          <a:xfrm>
+            <a:off x="3886200" y="5029200"/>
+            <a:ext cx="3592286" cy="5029200"/>
+          </a:xfrm>
+          <a:prstGeom prst="rect">
+            <a:avLst/>
+          </a:prstGeom>
+        </p:spPr>
+      </p:pic>
+      <p:pic>
+        <p:nvPicPr>
+          <p:cNvPr id="20" name="Picture 19" descr="A white and black card with text and images&#10;&#10;AI-generated content may be incorrect.">
+            <a:extLst>
+              <a:ext uri="{FF2B5EF4-FFF2-40B4-BE49-F238E27FC236}">
+                <a16:creationId xmlns:a16="http://schemas.microsoft.com/office/drawing/2014/main" id="{E2ABDBCD-044D-8FEC-7BAD-58C6994EA3DB}"/>
               </a:ext>
             </a:extLst>
           </p:cNvPr>
@@ -3487,42 +3450,6 @@
         </p:blipFill>
         <p:spPr>
           <a:xfrm>
-            <a:off x="3886200" y="4897582"/>
-            <a:ext cx="3592286" cy="5029200"/>
-          </a:xfrm>
-          <a:prstGeom prst="rect">
-            <a:avLst/>
-          </a:prstGeom>
-        </p:spPr>
-      </p:pic>
-      <p:pic>
-        <p:nvPicPr>
-          <p:cNvPr id="20" name="Picture 19" descr="A white and black card with text and images&#10;&#10;AI-generated content may be incorrect.">
-            <a:extLst>
-              <a:ext uri="{FF2B5EF4-FFF2-40B4-BE49-F238E27FC236}">
-                <a16:creationId xmlns:a16="http://schemas.microsoft.com/office/drawing/2014/main" id="{E2ABDBCD-044D-8FEC-7BAD-58C6994EA3DB}"/>
-              </a:ext>
-            </a:extLst>
-          </p:cNvPr>
-          <p:cNvPicPr>
-            <a:picLocks noChangeAspect="1"/>
-          </p:cNvPicPr>
-          <p:nvPr/>
-        </p:nvPicPr>
-        <p:blipFill>
-          <a:blip r:embed="rId4">
-            <a:extLst>
-              <a:ext uri="{28A0092B-C50C-407E-A947-70E740481C1C}">
-                <a14:useLocalDpi xmlns:a14="http://schemas.microsoft.com/office/drawing/2010/main" val="0"/>
-              </a:ext>
-            </a:extLst>
-          </a:blip>
-          <a:stretch>
-            <a:fillRect/>
-          </a:stretch>
-        </p:blipFill>
-        <p:spPr>
-          <a:xfrm>
             <a:off x="3886200" y="0"/>
             <a:ext cx="3592286" cy="5029200"/>
           </a:xfrm>
@@ -3531,6 +3458,121 @@
           </a:prstGeom>
         </p:spPr>
       </p:pic>
+      <p:grpSp>
+        <p:nvGrpSpPr>
+          <p:cNvPr id="22" name="Group 21">
+            <a:extLst>
+              <a:ext uri="{FF2B5EF4-FFF2-40B4-BE49-F238E27FC236}">
+                <a16:creationId xmlns:a16="http://schemas.microsoft.com/office/drawing/2014/main" id="{46F9933D-CB73-2541-E1E8-126BD76BF377}"/>
+              </a:ext>
+            </a:extLst>
+          </p:cNvPr>
+          <p:cNvGrpSpPr/>
+          <p:nvPr/>
+        </p:nvGrpSpPr>
+        <p:grpSpPr>
+          <a:xfrm>
+            <a:off x="471366" y="1639923"/>
+            <a:ext cx="2957285" cy="6778554"/>
+            <a:chOff x="421262" y="1570073"/>
+            <a:chExt cx="2957285" cy="6778554"/>
+          </a:xfrm>
+        </p:grpSpPr>
+        <p:pic>
+          <p:nvPicPr>
+            <p:cNvPr id="1036" name="Picture 12" descr="3 Head Flesh Monster Monster Design, Monster Art, Fantasy - Bonework Amalgam (503x604), Png Download">
+              <a:extLst>
+                <a:ext uri="{FF2B5EF4-FFF2-40B4-BE49-F238E27FC236}">
+                  <a16:creationId xmlns:a16="http://schemas.microsoft.com/office/drawing/2014/main" id="{5FEE716B-E3B0-F16F-0D0C-CAB7F7B13D3A}"/>
+                </a:ext>
+              </a:extLst>
+            </p:cNvPr>
+            <p:cNvPicPr>
+              <a:picLocks noChangeAspect="1" noChangeArrowheads="1"/>
+            </p:cNvPicPr>
+            <p:nvPr/>
+          </p:nvPicPr>
+          <p:blipFill>
+            <a:blip r:embed="rId4">
+              <a:extLst>
+                <a:ext uri="{28A0092B-C50C-407E-A947-70E740481C1C}">
+                  <a14:useLocalDpi xmlns:a14="http://schemas.microsoft.com/office/drawing/2010/main" val="0"/>
+                </a:ext>
+              </a:extLst>
+            </a:blip>
+            <a:srcRect/>
+            <a:stretch>
+              <a:fillRect/>
+            </a:stretch>
+          </p:blipFill>
+          <p:spPr bwMode="auto">
+            <a:xfrm>
+              <a:off x="421262" y="1570073"/>
+              <a:ext cx="2957285" cy="3459127"/>
+            </a:xfrm>
+            <a:prstGeom prst="rect">
+              <a:avLst/>
+            </a:prstGeom>
+            <a:noFill/>
+            <a:extLst>
+              <a:ext uri="{909E8E84-426E-40DD-AFC4-6F175D3DCCD1}">
+                <a14:hiddenFill xmlns:a14="http://schemas.microsoft.com/office/drawing/2010/main">
+                  <a:solidFill>
+                    <a:srgbClr val="FFFFFF"/>
+                  </a:solidFill>
+                </a14:hiddenFill>
+              </a:ext>
+            </a:extLst>
+          </p:spPr>
+        </p:pic>
+        <p:pic>
+          <p:nvPicPr>
+            <p:cNvPr id="21" name="Picture 12" descr="3 Head Flesh Monster Monster Design, Monster Art, Fantasy - Bonework Amalgam (503x604), Png Download">
+              <a:extLst>
+                <a:ext uri="{FF2B5EF4-FFF2-40B4-BE49-F238E27FC236}">
+                  <a16:creationId xmlns:a16="http://schemas.microsoft.com/office/drawing/2014/main" id="{BCDF1A1A-629F-F682-1530-12D5FD23FF85}"/>
+                </a:ext>
+              </a:extLst>
+            </p:cNvPr>
+            <p:cNvPicPr>
+              <a:picLocks noChangeAspect="1" noChangeArrowheads="1"/>
+            </p:cNvPicPr>
+            <p:nvPr/>
+          </p:nvPicPr>
+          <p:blipFill>
+            <a:blip r:embed="rId4">
+              <a:extLst>
+                <a:ext uri="{28A0092B-C50C-407E-A947-70E740481C1C}">
+                  <a14:useLocalDpi xmlns:a14="http://schemas.microsoft.com/office/drawing/2010/main" val="0"/>
+                </a:ext>
+              </a:extLst>
+            </a:blip>
+            <a:srcRect/>
+            <a:stretch>
+              <a:fillRect/>
+            </a:stretch>
+          </p:blipFill>
+          <p:spPr bwMode="auto">
+            <a:xfrm flipV="1">
+              <a:off x="421262" y="4889500"/>
+              <a:ext cx="2957285" cy="3459127"/>
+            </a:xfrm>
+            <a:prstGeom prst="rect">
+              <a:avLst/>
+            </a:prstGeom>
+            <a:noFill/>
+            <a:extLst>
+              <a:ext uri="{909E8E84-426E-40DD-AFC4-6F175D3DCCD1}">
+                <a14:hiddenFill xmlns:a14="http://schemas.microsoft.com/office/drawing/2010/main">
+                  <a:solidFill>
+                    <a:srgbClr val="FFFFFF"/>
+                  </a:solidFill>
+                </a14:hiddenFill>
+              </a:ext>
+            </a:extLst>
+          </p:spPr>
+        </p:pic>
+      </p:grpSp>
     </p:spTree>
     <p:extLst>
       <p:ext uri="{BB962C8B-B14F-4D97-AF65-F5344CB8AC3E}">

</xml_diff>